<commit_message>
feat(guide): mettre à jour les PPTX dark et light (14 slides)
- Slide 12 Roadmap : V1 passe à 7 items (benchmark, citations IA,
  audits planifiés, content briefs, crawl 50p) ; V2 nettoyé (alertes
  régression retirées car désormais en V1)
- Nouvelle slide 14 "Nouvelles fonctionnalités 2026" insérée avant le CTA :
  6 features (Crawl multi-pages, CrUX API, Drift Alerts, Benchmark,
  AI Citation Monitoring, Content Briefs IA) — toutes marquées Disponible
- Dark PPTX : palette sombre conservée
- Light PPTX : couleurs adaptées au thème clair

Co-Authored-By: Claude Sonnet 4.6 <noreply@anthropic.com>
</commit_message>
<xml_diff>
--- a/guide/SEO-GEO-Presentation-Dark.pptx
+++ b/guide/SEO-GEO-Presentation-Dark.pptx
@@ -17,6 +17,7 @@
     <p:sldId id="265" r:id="rId11"/>
     <p:sldId id="266" r:id="rId12"/>
     <p:sldId id="267" r:id="rId13"/>
+    <p:sldId id="271" r:id="rId19"/>
     <p:sldId id="268" r:id="rId14"/>
   </p:sldIdLst>
   <p:sldSz cx="12192000" cy="6858000"/>
@@ -5541,531 +5542,8 @@
 </p:sld>
 </file>
 
-<file path=ppt/slides/slide12.xml><?xml version="1.0" encoding="utf-8"?>
-<p:sld xmlns:a="http://schemas.openxmlformats.org/drawingml/2006/main" xmlns:r="http://schemas.openxmlformats.org/officeDocument/2006/relationships" xmlns:p="http://schemas.openxmlformats.org/presentationml/2006/main">
-  <p:cSld>
-    <p:spTree>
-      <p:nvGrpSpPr>
-        <p:cNvPr id="1" name=""/>
-        <p:cNvGrpSpPr/>
-        <p:nvPr/>
-      </p:nvGrpSpPr>
-      <p:grpSpPr>
-        <a:xfrm>
-          <a:off x="0" y="0"/>
-          <a:ext cx="0" cy="0"/>
-          <a:chOff x="0" y="0"/>
-          <a:chExt cx="0" cy="0"/>
-        </a:xfrm>
-      </p:grpSpPr>
-      <p:sp>
-        <p:nvSpPr>
-          <p:cNvPr id="2" name="Title 1"/>
-          <p:cNvSpPr>
-            <a:spLocks noGrp="1"/>
-          </p:cNvSpPr>
-          <p:nvPr>
-            <p:ph type="title"/>
-          </p:nvPr>
-        </p:nvSpPr>
-        <p:spPr/>
-        <p:txBody>
-          <a:bodyPr wrap="square"/>
-          <a:lstStyle/>
-          <a:p>
-            <a:r>
-              <a:rPr sz="2800" b="1">
-                <a:solidFill>
-                  <a:srgbClr val="E2EAF4"/>
-                </a:solidFill>
-              </a:rPr>
-              <a:t>Agency Tool V1 → Self-serve SaaS V2</a:t>
-            </a:r>
-          </a:p>
-        </p:txBody>
-      </p:sp>
-      <p:sp>
-        <p:nvSpPr>
-          <p:cNvPr id="3" name="Text Placeholder 2"/>
-          <p:cNvSpPr>
-            <a:spLocks noGrp="1"/>
-          </p:cNvSpPr>
-          <p:nvPr>
-            <p:ph type="body" idx="1"/>
-          </p:nvPr>
-        </p:nvSpPr>
-        <p:spPr/>
-        <p:txBody>
-          <a:bodyPr wrap="square"/>
-          <a:lstStyle/>
-          <a:p>
-            <a:pPr>
-              <a:spcAft>
-                <a:spcPts val="400"/>
-              </a:spcAft>
-            </a:pPr>
-            <a:r>
-              <a:rPr sz="1000" b="1">
-                <a:solidFill>
-                  <a:srgbClr val="8AA0B8"/>
-                </a:solidFill>
-              </a:rPr>
-              <a:t>Dashboard interne :</a:t>
-            </a:r>
-            <a:r>
-              <a:rPr sz="1000" b="0">
-                <a:solidFill>
-                  <a:srgbClr val="8AA0B8"/>
-                </a:solidFill>
-              </a:rPr>
-              <a:t> Olivier lance et suit les audits. Le client reçoit uniquement le rapport.</a:t>
-            </a:r>
-          </a:p>
-          <a:p>
-            <a:pPr>
-              <a:spcAft>
-                <a:spcPts val="400"/>
-              </a:spcAft>
-            </a:pPr>
-            <a:r>
-              <a:rPr sz="1000" b="1">
-                <a:solidFill>
-                  <a:srgbClr val="8AA0B8"/>
-                </a:solidFill>
-              </a:rPr>
-              <a:t>Audit URL live :</a:t>
-            </a:r>
-            <a:r>
-              <a:rPr sz="1000" b="0">
-                <a:solidFill>
-                  <a:srgbClr val="8AA0B8"/>
-                </a:solidFill>
-              </a:rPr>
-              <a:t> 11 dimensions, score 100 pts, &lt; 10 min.</a:t>
-            </a:r>
-          </a:p>
-          <a:p>
-            <a:pPr>
-              <a:spcAft>
-                <a:spcPts val="400"/>
-              </a:spcAft>
-            </a:pPr>
-            <a:r>
-              <a:rPr sz="1000" b="1">
-                <a:solidFill>
-                  <a:srgbClr val="8AA0B8"/>
-                </a:solidFill>
-              </a:rPr>
-              <a:t>Rapport white-label :</a:t>
-            </a:r>
-            <a:r>
-              <a:rPr sz="1000" b="0">
-                <a:solidFill>
-                  <a:srgbClr val="8AA0B8"/>
-                </a:solidFill>
-              </a:rPr>
-              <a:t> web partageable + PDF, en français.</a:t>
-            </a:r>
-          </a:p>
-          <a:p>
-            <a:pPr>
-              <a:spcAft>
-                <a:spcPts val="400"/>
-              </a:spcAft>
-            </a:pPr>
-            <a:r>
-              <a:rPr sz="1000" b="1">
-                <a:solidFill>
-                  <a:srgbClr val="8AA0B8"/>
-                </a:solidFill>
-              </a:rPr>
-              <a:t>Pricing à la prestation :</a:t>
-            </a:r>
-            <a:r>
-              <a:rPr sz="1000" b="0">
-                <a:solidFill>
-                  <a:srgbClr val="8AA0B8"/>
-                </a:solidFill>
-              </a:rPr>
-              <a:t> tripwire + retainer.</a:t>
-            </a:r>
-          </a:p>
-          <a:p>
-            <a:pPr>
-              <a:spcAft>
-                <a:spcPts val="400"/>
-              </a:spcAft>
-            </a:pPr>
-            <a:endParaRPr sz="1000" b="0">
-              <a:solidFill>
-                <a:srgbClr val="8AA0B8"/>
-              </a:solidFill>
-            </a:endParaRPr>
-          </a:p>
-          <a:p>
-            <a:pPr>
-              <a:spcAft>
-                <a:spcPts val="400"/>
-              </a:spcAft>
-            </a:pPr>
-            <a:r>
-              <a:rPr sz="1000" b="0">
-                <a:solidFill>
-                  <a:srgbClr val="8AA0B8"/>
-                </a:solidFill>
-              </a:rPr>
-              <a:t>Objectif 90 jours :</a:t>
-            </a:r>
-          </a:p>
-          <a:p>
-            <a:pPr>
-              <a:spcAft>
-                <a:spcPts val="400"/>
-              </a:spcAft>
-            </a:pPr>
-            <a:r>
-              <a:rPr sz="1000" b="1">
-                <a:solidFill>
-                  <a:srgbClr val="8AA0B8"/>
-                </a:solidFill>
-              </a:rPr>
-              <a:t>→</a:t>
-            </a:r>
-            <a:r>
-              <a:rPr sz="1000" b="0">
-                <a:solidFill>
-                  <a:srgbClr val="8AA0B8"/>
-                </a:solidFill>
-              </a:rPr>
-              <a:t> 10+ audits livrés à de vrais clients</a:t>
-            </a:r>
-          </a:p>
-          <a:p>
-            <a:pPr>
-              <a:spcAft>
-                <a:spcPts val="400"/>
-              </a:spcAft>
-            </a:pPr>
-            <a:r>
-              <a:rPr sz="1000" b="1">
-                <a:solidFill>
-                  <a:srgbClr val="8AA0B8"/>
-                </a:solidFill>
-              </a:rPr>
-              <a:t>→</a:t>
-            </a:r>
-            <a:r>
-              <a:rPr sz="1000" b="0">
-                <a:solidFill>
-                  <a:srgbClr val="8AA0B8"/>
-                </a:solidFill>
-              </a:rPr>
-              <a:t> 3+ conversions tripwire → retainer</a:t>
-            </a:r>
-          </a:p>
-          <a:p>
-            <a:pPr>
-              <a:spcAft>
-                <a:spcPts val="400"/>
-              </a:spcAft>
-            </a:pPr>
-            <a:r>
-              <a:rPr sz="1000" b="1">
-                <a:solidFill>
-                  <a:srgbClr val="8AA0B8"/>
-                </a:solidFill>
-              </a:rPr>
-              <a:t>→</a:t>
-            </a:r>
-            <a:r>
-              <a:rPr sz="1000" b="0">
-                <a:solidFill>
-                  <a:srgbClr val="8AA0B8"/>
-                </a:solidFill>
-              </a:rPr>
-              <a:t> CSAT ≥ 4.3/5 sur les rapports</a:t>
-            </a:r>
-          </a:p>
-        </p:txBody>
-      </p:sp>
-      <p:sp>
-        <p:nvSpPr>
-          <p:cNvPr id="4" name="Text Placeholder 3"/>
-          <p:cNvSpPr>
-            <a:spLocks noGrp="1"/>
-          </p:cNvSpPr>
-          <p:nvPr>
-            <p:ph type="body" idx="2"/>
-          </p:nvPr>
-        </p:nvSpPr>
-        <p:spPr/>
-        <p:txBody>
-          <a:bodyPr wrap="square"/>
-          <a:lstStyle/>
-          <a:p>
-            <a:pPr>
-              <a:spcAft>
-                <a:spcPts val="400"/>
-              </a:spcAft>
-            </a:pPr>
-            <a:r>
-              <a:rPr sz="1000" b="1">
-                <a:solidFill>
-                  <a:srgbClr val="8AA0B8"/>
-                </a:solidFill>
-              </a:rPr>
-              <a:t>Signup public :</a:t>
-            </a:r>
-            <a:r>
-              <a:rPr sz="1000" b="0">
-                <a:solidFill>
-                  <a:srgbClr val="8AA0B8"/>
-                </a:solidFill>
-              </a:rPr>
-              <a:t> inscription directe, onboarding automatisé.</a:t>
-            </a:r>
-          </a:p>
-          <a:p>
-            <a:pPr>
-              <a:spcAft>
-                <a:spcPts val="400"/>
-              </a:spcAft>
-            </a:pPr>
-            <a:r>
-              <a:rPr sz="1000" b="1">
-                <a:solidFill>
-                  <a:srgbClr val="8AA0B8"/>
-                </a:solidFill>
-              </a:rPr>
-              <a:t>Dashboard client :</a:t>
-            </a:r>
-            <a:r>
-              <a:rPr sz="1000" b="0">
-                <a:solidFill>
-                  <a:srgbClr val="8AA0B8"/>
-                </a:solidFill>
-              </a:rPr>
-              <a:t> historique audits, comparaison, KPI continu.</a:t>
-            </a:r>
-          </a:p>
-          <a:p>
-            <a:pPr>
-              <a:spcAft>
-                <a:spcPts val="400"/>
-              </a:spcAft>
-            </a:pPr>
-            <a:r>
-              <a:rPr sz="1000" b="1">
-                <a:solidFill>
-                  <a:srgbClr val="8AA0B8"/>
-                </a:solidFill>
-              </a:rPr>
-              <a:t>Plans Stripe :</a:t>
-            </a:r>
-            <a:r>
-              <a:rPr sz="1000" b="0">
-                <a:solidFill>
-                  <a:srgbClr val="8AA0B8"/>
-                </a:solidFill>
-              </a:rPr>
-              <a:t> Free (1/mois) · Pro (10/mois) · Agence (illimité).</a:t>
-            </a:r>
-          </a:p>
-          <a:p>
-            <a:pPr>
-              <a:spcAft>
-                <a:spcPts val="400"/>
-              </a:spcAft>
-            </a:pPr>
-            <a:r>
-              <a:rPr sz="1000" b="1">
-                <a:solidFill>
-                  <a:srgbClr val="8AA0B8"/>
-                </a:solidFill>
-              </a:rPr>
-              <a:t>Code source :</a:t>
-            </a:r>
-            <a:r>
-              <a:rPr sz="1000" b="0">
-                <a:solidFill>
-                  <a:srgbClr val="8AA0B8"/>
-                </a:solidFill>
-              </a:rPr>
-              <a:t> upload ZIP + GitHub connect, audit pre-launch.</a:t>
-            </a:r>
-          </a:p>
-          <a:p>
-            <a:pPr>
-              <a:spcAft>
-                <a:spcPts val="400"/>
-              </a:spcAft>
-            </a:pPr>
-            <a:r>
-              <a:rPr sz="1000" b="1">
-                <a:solidFill>
-                  <a:srgbClr val="8AA0B8"/>
-                </a:solidFill>
-              </a:rPr>
-              <a:t>Alertes :</a:t>
-            </a:r>
-            <a:r>
-              <a:rPr sz="1000" b="0">
-                <a:solidFill>
-                  <a:srgbClr val="8AA0B8"/>
-                </a:solidFill>
-              </a:rPr>
-              <a:t> notification automatique si score régressé.</a:t>
-            </a:r>
-          </a:p>
-          <a:p>
-            <a:pPr>
-              <a:spcAft>
-                <a:spcPts val="400"/>
-              </a:spcAft>
-            </a:pPr>
-            <a:endParaRPr sz="1000" b="0">
-              <a:solidFill>
-                <a:srgbClr val="8AA0B8"/>
-              </a:solidFill>
-            </a:endParaRPr>
-          </a:p>
-          <a:p>
-            <a:pPr>
-              <a:spcAft>
-                <a:spcPts val="400"/>
-              </a:spcAft>
-            </a:pPr>
-            <a:r>
-              <a:rPr sz="1000" b="0">
-                <a:solidFill>
-                  <a:srgbClr val="8AA0B8"/>
-                </a:solidFill>
-              </a:rPr>
-              <a:t>Métriques V2 :</a:t>
-            </a:r>
-          </a:p>
-          <a:p>
-            <a:pPr>
-              <a:spcAft>
-                <a:spcPts val="400"/>
-              </a:spcAft>
-            </a:pPr>
-            <a:r>
-              <a:rPr sz="1000" b="1">
-                <a:solidFill>
-                  <a:srgbClr val="8AA0B8"/>
-                </a:solidFill>
-              </a:rPr>
-              <a:t>→</a:t>
-            </a:r>
-            <a:r>
-              <a:rPr sz="1000" b="0">
-                <a:solidFill>
-                  <a:srgbClr val="8AA0B8"/>
-                </a:solidFill>
-              </a:rPr>
-              <a:t> ≥ 50 signups/mois</a:t>
-            </a:r>
-          </a:p>
-          <a:p>
-            <a:pPr>
-              <a:spcAft>
-                <a:spcPts val="400"/>
-              </a:spcAft>
-            </a:pPr>
-            <a:r>
-              <a:rPr sz="1000" b="1">
-                <a:solidFill>
-                  <a:srgbClr val="8AA0B8"/>
-                </a:solidFill>
-              </a:rPr>
-              <a:t>→</a:t>
-            </a:r>
-            <a:r>
-              <a:rPr sz="1000" b="0">
-                <a:solidFill>
-                  <a:srgbClr val="8AA0B8"/>
-                </a:solidFill>
-              </a:rPr>
-              <a:t> ≥ 10 % conversion Free → Pro</a:t>
-            </a:r>
-          </a:p>
-        </p:txBody>
-      </p:sp>
-      <p:sp>
-        <p:nvSpPr>
-          <p:cNvPr id="5" name="TextBox 4"/>
-          <p:cNvSpPr txBox="1"/>
-          <p:nvPr/>
-        </p:nvSpPr>
-        <p:spPr>
-          <a:xfrm>
-            <a:off x="1005840" y="1828800"/>
-            <a:ext cx="4023360" cy="320040"/>
-          </a:xfrm>
-          <a:prstGeom prst="rect">
-            <a:avLst/>
-          </a:prstGeom>
-          <a:noFill/>
-        </p:spPr>
-        <p:txBody>
-          <a:bodyPr wrap="square">
-            <a:spAutoFit/>
-          </a:bodyPr>
-          <a:lstStyle/>
-          <a:p>
-            <a:pPr algn="l"/>
-            <a:r>
-              <a:rPr sz="900" b="1" i="0">
-                <a:solidFill>
-                  <a:srgbClr val="6366F1"/>
-                </a:solidFill>
-              </a:rPr>
-              <a:t>MAINTENANT — V1 AGENCY MODE</a:t>
-            </a:r>
-          </a:p>
-        </p:txBody>
-      </p:sp>
-      <p:sp>
-        <p:nvSpPr>
-          <p:cNvPr id="6" name="TextBox 5"/>
-          <p:cNvSpPr txBox="1"/>
-          <p:nvPr/>
-        </p:nvSpPr>
-        <p:spPr>
-          <a:xfrm>
-            <a:off x="6675120" y="1828800"/>
-            <a:ext cx="4023360" cy="320040"/>
-          </a:xfrm>
-          <a:prstGeom prst="rect">
-            <a:avLst/>
-          </a:prstGeom>
-          <a:noFill/>
-        </p:spPr>
-        <p:txBody>
-          <a:bodyPr wrap="square">
-            <a:spAutoFit/>
-          </a:bodyPr>
-          <a:lstStyle/>
-          <a:p>
-            <a:pPr algn="l"/>
-            <a:r>
-              <a:rPr sz="900" b="1" i="0">
-                <a:solidFill>
-                  <a:srgbClr val="7C3AED"/>
-                </a:solidFill>
-              </a:rPr>
-              <a:t>PROCHAINEMENT — V2 SELF-SERVE</a:t>
-            </a:r>
-          </a:p>
-        </p:txBody>
-      </p:sp>
-    </p:spTree>
-  </p:cSld>
-  <p:clrMapOvr>
-    <a:masterClrMapping/>
-  </p:clrMapOvr>
-</p:sld>
+<file path=ppt/slides/slide12.xml><?xml version="1.0" encoding="UTF-8" standalone="yes"?>
+<p:sld xmlns:a="http://schemas.openxmlformats.org/drawingml/2006/main" xmlns:r="http://schemas.openxmlformats.org/officeDocument/2006/relationships" xmlns:p="http://schemas.openxmlformats.org/presentationml/2006/main"><p:cSld><p:spTree><p:nvGrpSpPr><p:cNvPr id="1" name=""/><p:cNvGrpSpPr/><p:nvPr/></p:nvGrpSpPr><p:grpSpPr><a:xfrm><a:off x="0" y="0"/><a:ext cx="0" cy="0"/><a:chOff x="0" y="0"/><a:chExt cx="0" cy="0"/></a:xfrm></p:grpSpPr><p:sp><p:nvSpPr><p:cNvPr id="2" name="Title 1"/><p:cNvSpPr><a:spLocks noGrp="1"/></p:cNvSpPr><p:nvPr><p:ph type="title"/></p:nvPr></p:nvSpPr><p:spPr/><p:txBody><a:bodyPr wrap="square"/><a:lstStyle/><a:p><a:r><a:rPr sz="2800" b="1"><a:solidFill><a:srgbClr val="E2EAF4"/></a:solidFill></a:rPr><a:t>Agency Tool V1 → Self-serve SaaS V2</a:t></a:r></a:p></p:txBody></p:sp><p:sp><p:nvSpPr><p:cNvPr id="3" name="Text Placeholder 2"/><p:cNvSpPr><a:spLocks noGrp="1"/></p:cNvSpPr><p:nvPr><p:ph type="body" idx="1"/></p:nvSpPr><p:nvPr/></p:nvSpPr><p:spPr/><a:bodyPr wrap="square"/><a:lstStyle/><a:p><a:pPr><a:spcAft><a:spcPts val="400"/></a:spcAft></a:pPr><a:r><a:rPr sz="1000" b="1"><a:solidFill><a:srgbClr val="8AA0B8"/></a:solidFill></a:rPr><a:t>Dashboard multi-org :</a:t></a:r><a:r><a:rPr sz="1000" b="0"><a:solidFill><a:srgbClr val="8AA0B8"/></a:solidFill></a:rPr><a:t> lancer et suivre les audits, plusieurs organisations.</a:t></a:r></a:p><a:p><a:pPr><a:spcAft><a:spcPts val="400"/></a:spcAft></a:pPr><a:r><a:rPr sz="1000" b="1"><a:solidFill><a:srgbClr val="8AA0B8"/></a:solidFill></a:rPr><a:t>Audit URL live :</a:t></a:r><a:r><a:rPr sz="1000" b="0"><a:solidFill><a:srgbClr val="8AA0B8"/></a:solidFill></a:rPr><a:t> crawl jusqu&apos;à 50 pages, score 100 pts sur 11 dimensions.</a:t></a:r></a:p><a:p><a:pPr><a:spcAft><a:spcPts val="400"/></a:spcAft></a:pPr><a:r><a:rPr sz="1000" b="1"><a:solidFill><a:srgbClr val="8AA0B8"/></a:solidFill></a:rPr><a:t>Rapport white-label :</a:t></a:r><a:r><a:rPr sz="1000" b="0"><a:solidFill><a:srgbClr val="8AA0B8"/></a:solidFill></a:rPr><a:t> PDF + lien partageable, en français.</a:t></a:r></a:p><a:p><a:pPr><a:spcAft><a:spcPts val="400"/></a:spcAft></a:pPr><a:r><a:rPr sz="1000" b="1"><a:solidFill><a:srgbClr val="8AA0B8"/></a:solidFill></a:rPr><a:t>Benchmark concurrent :</a:t></a:r><a:r><a:rPr sz="1000" b="0"><a:solidFill><a:srgbClr val="8AA0B8"/></a:solidFill></a:rPr><a:t> jusqu&apos;à 5 sites simultanés, tableau de scores par phase.</a:t></a:r></a:p><a:p><a:pPr><a:spcAft><a:spcPts val="400"/></a:spcAft></a:pPr><a:r><a:rPr sz="1000" b="1"><a:solidFill><a:srgbClr val="8AA0B8"/></a:solidFill></a:rPr><a:t>Citations IA :</a:t></a:r><a:r><a:rPr sz="1000" b="0"><a:solidFill><a:srgbClr val="8AA0B8"/></a:solidFill></a:rPr><a:t> surveillance Perplexity &amp; OpenAI, mention rate en continu.</a:t></a:r></a:p><a:p><a:pPr><a:spcAft><a:spcPts val="400"/></a:spcAft></a:pPr><a:r><a:rPr sz="1000" b="1"><a:solidFill><a:srgbClr val="8AA0B8"/></a:solidFill></a:rPr><a:t>Audits planifiés :</a:t></a:r><a:r><a:rPr sz="1000" b="0"><a:solidFill><a:srgbClr val="8AA0B8"/></a:solidFill></a:rPr><a:t> alertes email si le score régresse de plus de 5 pts.</a:t></a:r></a:p><a:p><a:pPr><a:spcAft><a:spcPts val="400"/></a:spcAft></a:pPr><a:r><a:rPr sz="1000" b="1"><a:solidFill><a:srgbClr val="8AA0B8"/></a:solidFill></a:rPr><a:t>Content briefs IA :</a:t></a:r><a:r><a:rPr sz="1000" b="0"><a:solidFill><a:srgbClr val="8AA0B8"/></a:solidFill></a:rPr><a:t> briefs générés automatiquement post-audit par Claude.</a:t></a:r></a:p><a:p><a:pPr><a:spcAft><a:spcPts val="400"/></a:spcAft></a:pPr><a:endParaRPr sz="1000" b="0"><a:solidFill><a:srgbClr val="8AA0B8"/></a:solidFill></a:endParaRPr></a:p><a:p><a:pPr><a:spcAft><a:spcPts val="400"/></a:spcAft></a:pPr><a:r><a:rPr sz="1000" b="1"><a:solidFill><a:srgbClr val="8AA0B8"/></a:solidFill></a:rPr><a:t>Objectif 90 jours :</a:t></a:r></a:p><a:p><a:pPr><a:spcAft><a:spcPts val="400"/></a:spcAft></a:pPr><a:r><a:rPr sz="1000" b="1"><a:solidFill><a:srgbClr val="8AA0B8"/></a:solidFill></a:rPr><a:t>→</a:t></a:r><a:r><a:rPr sz="1000" b="0"><a:solidFill><a:srgbClr val="8AA0B8"/></a:solidFill></a:rPr><a:t> 10+ audits livrés à de vrais clients</a:t></a:r></a:p><a:p><a:pPr><a:spcAft><a:spcPts val="400"/></a:spcAft></a:pPr><a:r><a:rPr sz="1000" b="1"><a:solidFill><a:srgbClr val="8AA0B8"/></a:solidFill></a:rPr><a:t>→</a:t></a:r><a:r><a:rPr sz="1000" b="0"><a:solidFill><a:srgbClr val="8AA0B8"/></a:solidFill></a:rPr><a:t> 3+ conversions tripwire → retainer</a:t></a:r></a:p><a:p><a:pPr><a:spcAft><a:spcPts val="400"/></a:spcAft></a:pPr><a:r><a:rPr sz="1000" b="1"><a:solidFill><a:srgbClr val="8AA0B8"/></a:solidFill></a:rPr><a:t>→</a:t></a:r><a:r><a:rPr sz="1000" b="0"><a:solidFill><a:srgbClr val="8AA0B8"/></a:solidFill></a:rPr><a:t> CSAT ≥ 4.3/5 sur les rapports</a:t></a:r></a:p></p:txBody></p:sp><p:sp><p:nvSpPr><p:cNvPr id="4" name="Text Placeholder 3"/><p:cNvSpPr><a:spLocks noGrp="1"/></p:cNvSpPr><p:nvPr><p:ph type="body" idx="2"/></p:nvPr></p:nvSpPr><p:spPr/><p:txBody><a:bodyPr wrap="square"/><a:lstStyle/><a:p><a:pPr><a:spcAft><a:spcPts val="400"/></a:spcAft></a:pPr><a:r><a:rPr sz="1000" b="1"><a:solidFill><a:srgbClr val="8AA0B8"/></a:solidFill></a:rPr><a:t>Signup public :</a:t></a:r><a:r><a:rPr sz="1000" b="0"><a:solidFill><a:srgbClr val="8AA0B8"/></a:solidFill></a:rPr><a:t> inscription directe, onboarding automatisé.</a:t></a:r></a:p><a:p><a:pPr><a:spcAft><a:spcPts val="400"/></a:spcAft></a:pPr><a:r><a:rPr sz="1000" b="1"><a:solidFill><a:srgbClr val="8AA0B8"/></a:solidFill></a:rPr><a:t>Dashboard client :</a:t></a:r><a:r><a:rPr sz="1000" b="0"><a:solidFill><a:srgbClr val="8AA0B8"/></a:solidFill></a:rPr><a:t> historique audits, comparaison, KPI continu.</a:t></a:r></a:p><a:p><a:pPr><a:spcAft><a:spcPts val="400"/></a:spcAft></a:pPr><a:r><a:rPr sz="1000" b="1"><a:solidFill><a:srgbClr val="8AA0B8"/></a:solidFill></a:rPr><a:t>Plans Stripe :</a:t></a:r><a:r><a:rPr sz="1000" b="0"><a:solidFill><a:srgbClr val="8AA0B8"/></a:solidFill></a:rPr><a:t> Free (1/mois) · Pro (10/mois) · Agence (illimité).</a:t></a:r></a:p><a:p><a:pPr><a:spcAft><a:spcPts val="400"/></a:spcAft></a:pPr><a:r><a:rPr sz="1000" b="1"><a:solidFill><a:srgbClr val="8AA0B8"/></a:solidFill></a:rPr><a:t>Code source :</a:t></a:r><a:r><a:rPr sz="1000" b="0"><a:solidFill><a:srgbClr val="8AA0B8"/></a:solidFill></a:rPr><a:t> upload ZIP + GitHub connect, audit pre-launch.</a:t></a:r></a:p><a:p><a:pPr><a:spcAft><a:spcPts val="400"/></a:spcAft></a:pPr><a:endParaRPr sz="1000" b="0"><a:solidFill><a:srgbClr val="8AA0B8"/></a:solidFill></a:endParaRPr></a:p><a:p><a:pPr><a:spcAft><a:spcPts val="400"/></a:spcAft></a:pPr><a:r><a:rPr sz="1000" b="1"><a:solidFill><a:srgbClr val="8AA0B8"/></a:solidFill></a:rPr><a:t>Métriques V2 :</a:t></a:r></a:p><a:p><a:pPr><a:spcAft><a:spcPts val="400"/></a:spcAft></a:pPr><a:r><a:rPr sz="1000" b="1"><a:solidFill><a:srgbClr val="8AA0B8"/></a:solidFill></a:rPr><a:t>→</a:t></a:r><a:r><a:rPr sz="1000" b="0"><a:solidFill><a:srgbClr val="8AA0B8"/></a:solidFill></a:rPr><a:t> ≥ 50 signups/mois</a:t></a:r></a:p><a:p><a:pPr><a:spcAft><a:spcPts val="400"/></a:spcAft></a:pPr><a:r><a:rPr sz="1000" b="1"><a:solidFill><a:srgbClr val="8AA0B8"/></a:solidFill></a:rPr><a:t>→</a:t></a:r><a:r><a:rPr sz="1000" b="0"><a:solidFill><a:srgbClr val="8AA0B8"/></a:solidFill></a:rPr><a:t> ≥ 10 % conversion Free → Pro</a:t></a:r></a:p></p:txBody></p:sp><p:sp><p:nvSpPr><p:cNvPr id="5" name="TextBox 4"/><p:cNvSpPr txBox="1"/><p:nvPr/></p:nvSpPr><p:spPr><a:xfrm><a:off x="1005840" y="1828800"/><a:ext cx="4023360" cy="320040"/></a:xfrm><a:prstGeom prst="rect"><a:avLst/></a:prstGeom><a:noFill/></p:spPr><p:txBody><a:bodyPr wrap="square"><a:spAutoFit/></a:bodyPr><a:lstStyle/><a:p><a:pPr algn="l"/><a:r><a:rPr sz="900" b="1" i="0"><a:solidFill><a:srgbClr val="6366F1"/></a:solidFill></a:rPr><a:t>MAINTENANT — V1 AGENCY MODE</a:t></a:r></a:p></p:txBody></p:sp><p:sp><p:nvSpPr><p:cNvPr id="6" name="TextBox 5"/><p:cNvSpPr txBox="1"/><p:nvPr/></p:nvSpPr><p:spPr><a:xfrm><a:off x="6675120" y="1828800"/><a:ext cx="4023360" cy="320040"/></a:xfrm><a:prstGeom prst="rect"><a:avLst/></a:prstGeom><a:noFill/></p:spPr><p:txBody><a:bodyPr wrap="square"><a:spAutoFit/></a:bodyPr><a:lstStyle/><a:p><a:pPr algn="l"/><a:r><a:rPr sz="900" b="1" i="0"><a:solidFill><a:srgbClr val="7C3AED"/></a:solidFill></a:rPr><a:t>PROCHAINEMENT — V2 SELF-SERVE</a:t></a:r></a:p></p:txBody></p:sp></p:spTree></p:cSld><p:clrMapOvr><a:masterClrMapping/></p:clrMapOvr></p:sld>
 </file>
 
 <file path=ppt/slides/slide13.xml><?xml version="1.0" encoding="utf-8"?>
@@ -6165,6 +5643,340 @@
               </a:rPr>
               <a:t>Entrez une URL. Obtenez un rapport complet en moins de 10 minutes.
 White-label, en français, livrable client immédiatement.</a:t>
+            </a:r>
+          </a:p>
+        </p:txBody>
+      </p:sp>
+    </p:spTree>
+  </p:cSld>
+  <p:clrMapOvr>
+    <a:masterClrMapping/>
+  </p:clrMapOvr>
+</p:sld>
+</file>
+
+<file path=ppt/slides/slide14.xml><?xml version="1.0" encoding="utf-8"?>
+<p:sld xmlns:a="http://schemas.openxmlformats.org/drawingml/2006/main" xmlns:r="http://schemas.openxmlformats.org/officeDocument/2006/relationships" xmlns:p="http://schemas.openxmlformats.org/presentationml/2006/main">
+  <p:cSld>
+    <p:spTree>
+      <p:nvGrpSpPr>
+        <p:cNvPr id="1" name=""/>
+        <p:cNvGrpSpPr/>
+        <p:nvPr/>
+      </p:nvGrpSpPr>
+      <p:grpSpPr>
+        <a:xfrm>
+          <a:off x="0" y="0"/>
+          <a:ext cx="0" cy="0"/>
+          <a:chOff x="0" y="0"/>
+          <a:chExt cx="0" cy="0"/>
+        </a:xfrm>
+      </p:grpSpPr>
+      <p:sp>
+        <p:nvSpPr>
+          <p:cNvPr id="2" name="Title 1"/>
+          <p:cNvSpPr>
+            <a:spLocks noGrp="1"/>
+          </p:cNvSpPr>
+          <p:nvPr>
+            <p:ph type="title"/>
+          </p:nvPr>
+        </p:nvSpPr>
+        <p:spPr/>
+        <p:txBody>
+          <a:bodyPr wrap="square"/>
+          <a:lstStyle/>
+          <a:p>
+            <a:r>
+              <a:rPr sz="2800" b="1">
+                <a:solidFill>
+                  <a:srgbClr val="E2EAF4"/>
+                </a:solidFill>
+              </a:rPr>
+              <a:t>Ce qui est arrivé en 2026.</a:t>
+            </a:r>
+          </a:p>
+        </p:txBody>
+      </p:sp>
+      <p:sp>
+        <p:nvSpPr>
+          <p:cNvPr id="3" name="Body 2"/>
+          <p:cNvSpPr>
+            <a:spLocks noGrp="1"/>
+          </p:cNvSpPr>
+          <p:nvPr>
+            <p:ph type="body" idx="1"/>
+          </p:nvPr>
+        </p:nvSpPr>
+        <p:spPr/>
+        <p:txBody>
+          <a:bodyPr wrap="square"/>
+          <a:lstStyle/>
+          <a:p>
+            <a:pPr>
+              <a:spcAft>
+                <a:spcPts val="100"/>
+              </a:spcAft>
+            </a:pPr>
+            <a:r>
+              <a:rPr sz="750" b="1">
+                <a:solidFill>
+                  <a:srgbClr val="FF6B2C"/>
+                </a:solidFill>
+              </a:rPr>
+              <a:t>Phase 01·09·10 — </a:t>
+            </a:r>
+            <a:r>
+              <a:rPr sz="850" b="1">
+                <a:solidFill>
+                  <a:srgbClr val="E2EAF4"/>
+                </a:solidFill>
+              </a:rPr>
+              <a:t>Crawl multi-pages (50 pages)</a:t>
+            </a:r>
+          </a:p>
+          <a:p>
+            <a:pPr>
+              <a:spcAft>
+                <a:spcPts val="500"/>
+              </a:spcAft>
+              <a:ind l="120000"/>
+            </a:pPr>
+            <a:r>
+              <a:rPr sz="750" b="0">
+                <a:solidFill>
+                  <a:srgbClr val="8AA0B8"/>
+                </a:solidFill>
+              </a:rPr>
+              <a:t>BFS sur 50 pages : pillar pages, clusters thématiques, pages orphelines. Détection de cannibalisation.</a:t>
+            </a:r>
+          </a:p>
+          <a:p>
+            <a:pPr>
+              <a:spcAft>
+                <a:spcPts val="100"/>
+              </a:spcAft>
+            </a:pPr>
+            <a:r>
+              <a:rPr sz="750" b="1">
+                <a:solidFill>
+                  <a:srgbClr val="00C2FF"/>
+                </a:solidFill>
+              </a:rPr>
+              <a:t>Phase 08 — Perf. — </a:t>
+            </a:r>
+            <a:r>
+              <a:rPr sz="850" b="1">
+                <a:solidFill>
+                  <a:srgbClr val="E2EAF4"/>
+                </a:solidFill>
+              </a:rPr>
+              <a:t>CrUX API réelle</a:t>
+            </a:r>
+          </a:p>
+          <a:p>
+            <a:pPr>
+              <a:spcAft>
+                <a:spcPts val="500"/>
+              </a:spcAft>
+              <a:ind l="120000"/>
+            </a:pPr>
+            <a:r>
+              <a:rPr sz="750" b="0">
+                <a:solidFill>
+                  <a:srgbClr val="8AA0B8"/>
+                </a:solidFill>
+              </a:rPr>
+              <a:t>LCP, INP, CLS terrain via Google Chrome UX Report. Données réelles, pas des simulations Lighthouse.</a:t>
+            </a:r>
+          </a:p>
+          <a:p>
+            <a:pPr>
+              <a:spcAft>
+                <a:spcPts val="100"/>
+              </a:spcAft>
+            </a:pPr>
+            <a:r>
+              <a:rPr sz="750" b="1">
+                <a:solidFill>
+                  <a:srgbClr val="F59E0B"/>
+                </a:solidFill>
+              </a:rPr>
+              <a:t>Monitoring continu — </a:t>
+            </a:r>
+            <a:r>
+              <a:rPr sz="850" b="1">
+                <a:solidFill>
+                  <a:srgbClr val="E2EAF4"/>
+                </a:solidFill>
+              </a:rPr>
+              <a:t>Score Drift Alerts</a:t>
+            </a:r>
+          </a:p>
+          <a:p>
+            <a:pPr>
+              <a:spcAft>
+                <a:spcPts val="500"/>
+              </a:spcAft>
+              <a:ind l="120000"/>
+            </a:pPr>
+            <a:r>
+              <a:rPr sz="750" b="0">
+                <a:solidFill>
+                  <a:srgbClr val="8AA0B8"/>
+                </a:solidFill>
+              </a:rPr>
+              <a:t>Alerte email si le score chute de +5 pts entre deux re-audits planifiés. Réagissez avant le client.</a:t>
+            </a:r>
+          </a:p>
+          <a:p>
+            <a:pPr>
+              <a:spcAft>
+                <a:spcPts val="100"/>
+              </a:spcAft>
+            </a:pPr>
+            <a:r>
+              <a:rPr sz="750" b="1">
+                <a:solidFill>
+                  <a:srgbClr val="06B6D4"/>
+                </a:solidFill>
+              </a:rPr>
+              <a:t>Nouveau — </a:t>
+            </a:r>
+            <a:r>
+              <a:rPr sz="850" b="1">
+                <a:solidFill>
+                  <a:srgbClr val="E2EAF4"/>
+                </a:solidFill>
+              </a:rPr>
+              <a:t>Benchmark concurrent</a:t>
+            </a:r>
+          </a:p>
+          <a:p>
+            <a:pPr>
+              <a:spcAft>
+                <a:spcPts val="500"/>
+              </a:spcAft>
+              <a:ind l="120000"/>
+            </a:pPr>
+            <a:r>
+              <a:rPr sz="750" b="0">
+                <a:solidFill>
+                  <a:srgbClr val="8AA0B8"/>
+                </a:solidFill>
+              </a:rPr>
+              <a:t>Comparatif multi-URL, jusqu'à 5 sites. Tableau de scores par phase — position vs concurrence.</a:t>
+            </a:r>
+          </a:p>
+          <a:p>
+            <a:pPr>
+              <a:spcAft>
+                <a:spcPts val="100"/>
+              </a:spcAft>
+            </a:pPr>
+            <a:r>
+              <a:rPr sz="750" b="1">
+                <a:solidFill>
+                  <a:srgbClr val="7C3AED"/>
+                </a:solidFill>
+              </a:rPr>
+              <a:t>Phase 03 — GEO — </a:t>
+            </a:r>
+            <a:r>
+              <a:rPr sz="850" b="1">
+                <a:solidFill>
+                  <a:srgbClr val="E2EAF4"/>
+                </a:solidFill>
+              </a:rPr>
+              <a:t>AI Citation Monitoring</a:t>
+            </a:r>
+          </a:p>
+          <a:p>
+            <a:pPr>
+              <a:spcAft>
+                <a:spcPts val="500"/>
+              </a:spcAft>
+              <a:ind l="120000"/>
+            </a:pPr>
+            <a:r>
+              <a:rPr sz="750" b="0">
+                <a:solidFill>
+                  <a:srgbClr val="8AA0B8"/>
+                </a:solidFill>
+              </a:rPr>
+              <a:t>Votre domaine est-il cité par Perplexity et ChatGPT sur vos requêtes cibles ? Suivi en continu.</a:t>
+            </a:r>
+          </a:p>
+          <a:p>
+            <a:pPr>
+              <a:spcAft>
+                <a:spcPts val="100"/>
+              </a:spcAft>
+            </a:pPr>
+            <a:r>
+              <a:rPr sz="750" b="1">
+                <a:solidFill>
+                  <a:srgbClr val="10B981"/>
+                </a:solidFill>
+              </a:rPr>
+              <a:t>Post-audit — </a:t>
+            </a:r>
+            <a:r>
+              <a:rPr sz="850" b="1">
+                <a:solidFill>
+                  <a:srgbClr val="E2EAF4"/>
+                </a:solidFill>
+              </a:rPr>
+              <a:t>Content Briefs IA</a:t>
+            </a:r>
+          </a:p>
+          <a:p>
+            <a:pPr>
+              <a:spcAft>
+                <a:spcPts val="500"/>
+              </a:spcAft>
+              <a:ind l="120000"/>
+            </a:pPr>
+            <a:r>
+              <a:rPr sz="750" b="0">
+                <a:solidFill>
+                  <a:srgbClr val="8AA0B8"/>
+                </a:solidFill>
+              </a:rPr>
+              <a:t>Briefs de contenu générés automatiquement — structure, angle, mots-clés, signaux E-E-A-T. Par Claude.</a:t>
+            </a:r>
+          </a:p>
+        </p:txBody>
+      </p:sp>
+      <p:sp>
+        <p:nvSpPr>
+          <p:cNvPr id="4" name="TextBox 3"/>
+          <p:cNvSpPr txBox="1"/>
+          <p:nvPr/>
+        </p:nvSpPr>
+        <p:spPr>
+          <a:xfrm>
+            <a:off x="1005840" y="820000"/>
+            <a:ext cx="6000000" cy="300000"/>
+          </a:xfrm>
+          <a:prstGeom prst="rect">
+            <a:avLst/>
+          </a:prstGeom>
+          <a:noFill/>
+        </p:spPr>
+        <p:txBody>
+          <a:bodyPr wrap="square">
+            <a:spAutoFit/>
+          </a:bodyPr>
+          <a:lstStyle/>
+          <a:p>
+            <a:r>
+              <a:rPr sz="900" b="1">
+                <a:solidFill>
+                  <a:srgbClr val="FF6B2C"/>
+                </a:solidFill>
+              </a:rPr>
+              <a:t>11 — NOUVELLES FONCTIONNALITÉS</a:t>
             </a:r>
           </a:p>
         </p:txBody>

</xml_diff>